<commit_message>
docs(ppt): add Romanian diacritics
</commit_message>
<xml_diff>
--- a/docs/ppt/ARTERIA.pptx
+++ b/docs/ppt/ARTERIA.pptx
@@ -160,7 +160,7 @@
     </p:spTree>
     <p:extLst>
       <p:ext uri="{BB962C8B-B14F-4D97-AF65-F5344CB8AC3E}">
-        <p14:creationId xmlns:p14="http://schemas.microsoft.com/office/powerpoint/2010/main" val="4130215371"/>
+        <p14:creationId xmlns:p14="http://schemas.microsoft.com/office/powerpoint/2010/main" val="1550183002"/>
       </p:ext>
     </p:extLst>
   </p:cSld>
@@ -1204,7 +1204,7 @@
           </a:p>
           <a:p>
             <a:r>
-              <a:t>Echipa a furnizat numele și responsabilitățile: Iustin Fagateanu — interfață/frontend; Alex Pintilie — inițializarea proiectului și baza de simulare; Fagateanu Eusebiu — backend. Traducerea păstrează aceste roluri, fără atribuirea unor endpoint-uri, algoritmi sau rezultate individuale pe care dovezile nu le stabilesc. Continuitatea după eveniment, rolurile de scenă și experiența profesională nu sunt confirmate.</a:t>
+              <a:t>Echipa a furnizat numele și responsabilitățile: Iustin Făgăteanu — interfață/frontend; Alex Pintilie — inițializarea proiectului și baza de simulare; Făgăteanu Eusebiu — backend. Traducerea păstrează aceste roluri, fără atribuirea unor endpoint-uri, algoritmi sau rezultate individuale pe care dovezile nu le stabilesc. Continuitatea după eveniment, rolurile de scenă și experiența profesională nu sunt confirmate.</a:t>
             </a:r>
           </a:p>
           <a:p>
@@ -13323,7 +13323,7 @@
         </p:sp>
         <p:sp>
           <p:nvSpPr>
-            <p:cNvPr id="7" name="Text: Iustin Fagateanu"/>
+            <p:cNvPr id="7" name="Text: Iustin Făgăteanu"/>
             <p:cNvSpPr txBox="1"/>
             <p:nvPr/>
           </p:nvSpPr>
@@ -13359,7 +13359,7 @@
                   </a:solidFill>
                   <a:latin typeface="Calibri"/>
                 </a:rPr>
-                <a:t>Iustin Fagateanu</a:t>
+                <a:t>Iustin Făgăteanu</a:t>
               </a:r>
             </a:p>
           </p:txBody>
@@ -13653,7 +13653,7 @@
         </p:sp>
         <p:sp>
           <p:nvSpPr>
-            <p:cNvPr id="15" name="Text: Fagateanu Eusebiu"/>
+            <p:cNvPr id="15" name="Text: Făgăteanu Eusebiu"/>
             <p:cNvSpPr txBox="1"/>
             <p:nvPr/>
           </p:nvSpPr>
@@ -13689,7 +13689,7 @@
                   </a:solidFill>
                   <a:latin typeface="Calibri"/>
                 </a:rPr>
-                <a:t>Fagateanu Eusebiu</a:t>
+                <a:t>Făgăteanu Eusebiu</a:t>
               </a:r>
             </a:p>
           </p:txBody>

</xml_diff>